<commit_message>
Replace jargon with plain language for non-cycling audience
Cycling terms: drivetrain -> gears + brakes, cockpit -> handlebars,
clipless -> lock-in, firmware -> software updates, telemetry -> usage data.
Tech stack: Zendesk/Kendra/Bedrock -> plain descriptions, CRM -> customer
records, OEM -> bike manufacturers, DTC/Velocio -> online store/apparel brand.
Shimano tagged as SRAM's largest competitor for context.
</commit_message>
<xml_diff>
--- a/deliverables/SRAM_AI_Adoption_Playbook.pptx
+++ b/deliverables/SRAM_AI_Adoption_Playbook.pptx
@@ -3625,7 +3625,7 @@
             </a:r>
             <a:br/>
             <a:r>
-              <a:t>submits via Zendesk</a:t>
+              <a:t>submits a question</a:t>
             </a:r>
           </a:p>
         </p:txBody>
@@ -3839,11 +3839,11 @@
               </a:defRPr>
             </a:pPr>
             <a:r>
-              <a:t>Amazon Kendra</a:t>
+              <a:t>AI searches SRAM's</a:t>
             </a:r>
             <a:br/>
             <a:r>
-              <a:t>finds approved docs</a:t>
+              <a:t>approved documents</a:t>
             </a:r>
           </a:p>
         </p:txBody>
@@ -4057,11 +4057,11 @@
               </a:defRPr>
             </a:pPr>
             <a:r>
-              <a:t>Amazon Bedrock</a:t>
+              <a:t>AI writes a</a:t>
             </a:r>
             <a:br/>
             <a:r>
-              <a:t>from knowledge base</a:t>
+              <a:t>proposed answer</a:t>
             </a:r>
           </a:p>
         </p:txBody>
@@ -4275,7 +4275,7 @@
               </a:defRPr>
             </a:pPr>
             <a:r>
-              <a:t>Agent approves</a:t>
+              <a:t>Support agent approves</a:t>
             </a:r>
             <a:br/>
             <a:r>
@@ -4885,7 +4885,7 @@
             </a:r>
             <a:br/>
             <a:r>
-              <a:t>submits via Zendesk</a:t>
+              <a:t>submits a question</a:t>
             </a:r>
           </a:p>
         </p:txBody>
@@ -5099,11 +5099,11 @@
               </a:defRPr>
             </a:pPr>
             <a:r>
-              <a:t>Amazon Kendra</a:t>
+              <a:t>AI searches SRAM's</a:t>
             </a:r>
             <a:br/>
             <a:r>
-              <a:t>finds approved docs</a:t>
+              <a:t>approved documents</a:t>
             </a:r>
           </a:p>
         </p:txBody>
@@ -5317,11 +5317,11 @@
               </a:defRPr>
             </a:pPr>
             <a:r>
-              <a:t>Amazon Bedrock</a:t>
+              <a:t>AI writes a</a:t>
             </a:r>
             <a:br/>
             <a:r>
-              <a:t>from knowledge base</a:t>
+              <a:t>proposed answer</a:t>
             </a:r>
           </a:p>
         </p:txBody>
@@ -5535,7 +5535,7 @@
               </a:defRPr>
             </a:pPr>
             <a:r>
-              <a:t>Agent approves</a:t>
+              <a:t>Support agent approves</a:t>
             </a:r>
             <a:br/>
             <a:r>
@@ -6411,7 +6411,7 @@
               </a:defRPr>
             </a:pPr>
             <a:r>
-              <a:t>Measured weekly vs. SLA baseline</a:t>
+              <a:t>Measured weekly vs. current baseline</a:t>
             </a:r>
           </a:p>
         </p:txBody>
@@ -6867,7 +6867,7 @@
               </a:defRPr>
             </a:pPr>
             <a:r>
-              <a:t>Measured weekly vs. SLA baseline</a:t>
+              <a:t>Measured weekly vs. current baseline</a:t>
             </a:r>
           </a:p>
         </p:txBody>
@@ -7485,7 +7485,7 @@
               </a:defRPr>
             </a:pPr>
             <a:r>
-              <a:t>Measured weekly vs. SLA baseline</a:t>
+              <a:t>Measured weekly vs. current baseline</a:t>
             </a:r>
           </a:p>
         </p:txBody>
@@ -8310,7 +8310,7 @@
               </a:defRPr>
             </a:pPr>
             <a:r>
-              <a:t>Measured weekly vs. SLA baseline</a:t>
+              <a:t>Measured weekly vs. current baseline</a:t>
             </a:r>
           </a:p>
         </p:txBody>
@@ -9297,7 +9297,7 @@
               </a:defRPr>
             </a:pPr>
             <a:r>
-              <a:t>Measured weekly vs. SLA baseline</a:t>
+              <a:t>Measured weekly vs. current baseline</a:t>
             </a:r>
           </a:p>
         </p:txBody>
@@ -10640,7 +10640,7 @@
               </a:defRPr>
             </a:pPr>
             <a:r>
-              <a:t>Zendesk + Kendra + Bedrock integration; baseline metrics</a:t>
+              <a:t>Connect support system to AI tools; set baseline metrics</a:t>
             </a:r>
           </a:p>
         </p:txBody>
@@ -11290,7 +11290,7 @@
               </a:defRPr>
             </a:pPr>
             <a:r>
-              <a:t>Zendesk + Kendra + Bedrock integration; baseline metrics</a:t>
+              <a:t>Connect support system to AI tools; set baseline metrics</a:t>
             </a:r>
           </a:p>
         </p:txBody>
@@ -12307,7 +12307,7 @@
               </a:defRPr>
             </a:pPr>
             <a:r>
-              <a:t>CSAT Monitoring</a:t>
+              <a:t>Satisfaction Monitoring</a:t>
             </a:r>
           </a:p>
         </p:txBody>
@@ -12993,7 +12993,7 @@
               </a:defRPr>
             </a:pPr>
             <a:r>
-              <a:t>Zendesk + Kendra + Bedrock integration; baseline metrics</a:t>
+              <a:t>Connect support system to AI tools; set baseline metrics</a:t>
             </a:r>
           </a:p>
         </p:txBody>
@@ -14010,7 +14010,7 @@
               </a:defRPr>
             </a:pPr>
             <a:r>
-              <a:t>CSAT Monitoring</a:t>
+              <a:t>Satisfaction Monitoring</a:t>
             </a:r>
           </a:p>
         </p:txBody>
@@ -14900,7 +14900,7 @@
               </a:defRPr>
             </a:pPr>
             <a:r>
-              <a:t>Drivetrains + Braking</a:t>
+              <a:t>Gears + Brakes</a:t>
             </a:r>
           </a:p>
         </p:txBody>
@@ -14936,11 +14936,11 @@
               </a:defRPr>
             </a:pPr>
             <a:r>
-              <a:t>Gears, chains, and disc</a:t>
+              <a:t>The parts that make</a:t>
             </a:r>
             <a:br/>
             <a:r>
-              <a:t>brakes for every bike</a:t>
+              <a:t>a bike shift and stop</a:t>
             </a:r>
           </a:p>
         </p:txBody>
@@ -15095,11 +15095,11 @@
               </a:defRPr>
             </a:pPr>
             <a:r>
-              <a:t>Forks that absorb</a:t>
+              <a:t>Shock absorbers that</a:t>
             </a:r>
             <a:br/>
             <a:r>
-              <a:t>bumps on trails</a:t>
+              <a:t>smooth out rough terrain</a:t>
             </a:r>
           </a:p>
         </p:txBody>
@@ -15218,7 +15218,7 @@
               </a:defRPr>
             </a:pPr>
             <a:r>
-              <a:t>Wheels + Cockpit</a:t>
+              <a:t>Wheels + Handlebars</a:t>
             </a:r>
           </a:p>
         </p:txBody>
@@ -15254,11 +15254,11 @@
               </a:defRPr>
             </a:pPr>
             <a:r>
-              <a:t>Aero wheels built</a:t>
+              <a:t>Lightweight wheels</a:t>
             </a:r>
             <a:br/>
             <a:r>
-              <a:t>for speed</a:t>
+              <a:t>built for speed</a:t>
             </a:r>
           </a:p>
         </p:txBody>
@@ -15417,7 +15417,7 @@
             </a:r>
             <a:br/>
             <a:r>
-              <a:t>rider performance</a:t>
+              <a:t>how hard a rider pedals</a:t>
             </a:r>
           </a:p>
         </p:txBody>
@@ -15536,7 +15536,7 @@
               </a:defRPr>
             </a:pPr>
             <a:r>
-              <a:t>Cycling Computer</a:t>
+              <a:t>GPS Bike Computer</a:t>
             </a:r>
           </a:p>
         </p:txBody>
@@ -15572,11 +15572,11 @@
               </a:defRPr>
             </a:pPr>
             <a:r>
-              <a:t>GPS device for navigation,</a:t>
+              <a:t>On-bike screen for</a:t>
             </a:r>
             <a:br/>
             <a:r>
-              <a:t>training, and data</a:t>
+              <a:t>navigation and training data</a:t>
             </a:r>
           </a:p>
         </p:txBody>
@@ -15731,11 +15731,11 @@
               </a:defRPr>
             </a:pPr>
             <a:r>
-              <a:t>Clipless pedal systems</a:t>
+              <a:t>Pedal systems that lock</a:t>
             </a:r>
             <a:br/>
             <a:r>
-              <a:t>for road and mountain</a:t>
+              <a:t>into the rider's shoes</a:t>
             </a:r>
           </a:p>
         </p:txBody>
@@ -15771,7 +15771,7 @@
               </a:defRPr>
             </a:pPr>
             <a:r>
-              <a:t>6 brands. 1 connected ecosystem. From casual riders to elite athletes.</a:t>
+              <a:t>6 brands. 1 connected ecosystem. From weekend riders to Tour de France pros.</a:t>
             </a:r>
           </a:p>
         </p:txBody>
@@ -17268,7 +17268,7 @@
               </a:defRPr>
             </a:pPr>
             <a:r>
-              <a:t>Each capability creates a new recurring revenue stream. SRAM's installed base of connected components becomes a platform, not a one-time sale.</a:t>
+              <a:t>Each capability creates a new recurring revenue stream. SRAM's millions of connected bike parts become a software platform, not a one-time sale.</a:t>
             </a:r>
           </a:p>
         </p:txBody>
@@ -17466,7 +17466,7 @@
               </a:defRPr>
             </a:pPr>
             <a:r>
-              <a:t>Unified rider dashboard: power, gearing, suspension, heart rate in one view. No competitor has the product breadth to build this.</a:t>
+              <a:t>One dashboard showing power, gearing, suspension, and heart rate. No competitor sells enough product categories to build this.</a:t>
             </a:r>
           </a:p>
         </p:txBody>
@@ -17751,7 +17751,7 @@
               </a:defRPr>
             </a:pPr>
             <a:r>
-              <a:t>Each capability creates a new recurring revenue stream. SRAM's installed base of connected components becomes a platform, not a one-time sale.</a:t>
+              <a:t>Each capability creates a new recurring revenue stream. SRAM's millions of connected bike parts become a software platform, not a one-time sale.</a:t>
             </a:r>
           </a:p>
         </p:txBody>
@@ -17949,7 +17949,7 @@
               </a:defRPr>
             </a:pPr>
             <a:r>
-              <a:t>Unified rider dashboard: power, gearing, suspension, heart rate in one view. No competitor has the product breadth to build this.</a:t>
+              <a:t>One dashboard showing power, gearing, suspension, and heart rate. No competitor sells enough product categories to build this.</a:t>
             </a:r>
           </a:p>
         </p:txBody>
@@ -18104,7 +18104,7 @@
               </a:defRPr>
             </a:pPr>
             <a:r>
-              <a:t>Connected components predict chain and brake pad replacement before failure. Installed base becomes recurring revenue.</a:t>
+              <a:t>Connected parts predict when chains and brake pads need replacement before they fail. One-time sales become recurring revenue.</a:t>
             </a:r>
           </a:p>
         </p:txBody>
@@ -18259,7 +18259,7 @@
               </a:defRPr>
             </a:pPr>
             <a:r>
-              <a:t>Suspension auto-adjusts to terrain. Shifting optimizes for rider power. Products improve continuously after purchase.</a:t>
+              <a:t>Suspension auto-adjusts to terrain. Gears optimize for rider power. Products improve continuously after purchase.</a:t>
             </a:r>
           </a:p>
         </p:txBody>
@@ -18414,7 +18414,7 @@
               </a:defRPr>
             </a:pPr>
             <a:r>
-              <a:t>Telemetry tells dealers which parts approach end-of-life in their area. Proactive ordering replaces reactive.</a:t>
+              <a:t>Usage data tells bike shops which parts are wearing out in their area. Proactive ordering replaces reactive.</a:t>
             </a:r>
           </a:p>
         </p:txBody>
@@ -19357,11 +19357,15 @@
               </a:defRPr>
             </a:pPr>
             <a:r>
-              <a:t>Unified data layer linking CRM, inventory,</a:t>
+              <a:t>Unified data layer linking customer records,</a:t>
             </a:r>
             <a:br/>
             <a:r>
-              <a:t>and telemetry. Foundation for Phase 2-4.</a:t>
+              <a:t>inventory, and product usage data.</a:t>
+            </a:r>
+            <a:br/>
+            <a:r>
+              <a:t>Foundation for Phase 2-4.</a:t>
             </a:r>
           </a:p>
         </p:txBody>
@@ -20368,7 +20372,7 @@
               </a:defRPr>
             </a:pPr>
             <a:r>
-              <a:t>Unified data layer connecting Shopify, support systems, and telemetry. Foundation for Phase 2 forecasting and Phase 4 AXS Intelligence platform.</a:t>
+              <a:t>Unified data layer connecting e-commerce, support systems, and product usage data. Foundation for Phase 2 forecasting and Phase 4 AXS Intelligence platform.</a:t>
             </a:r>
           </a:p>
         </p:txBody>
@@ -23574,7 +23578,7 @@
               </a:defRPr>
             </a:pPr>
             <a:r>
-              <a:t>“A Shimano rider uses the app to check compatibility. A Hammerhead rider uses it to train, navigate, and communicate with their component stack. That is a fundamentally different data relationship.”</a:t>
+              <a:t>“A rider on Shimano [SRAM's largest competitor] uses the app to check if parts fit. A Hammerhead rider uses it to train, navigate, and talk to every component on the bike. That is a fundamentally different data relationship.”</a:t>
             </a:r>
           </a:p>
         </p:txBody>
@@ -24175,7 +24179,7 @@
               </a:defRPr>
             </a:pPr>
             <a:r>
-              <a:t>•  Zendesk AI + Amazon Kendra + Bedrock</a:t>
+              <a:t>•  AI support tools (document search + response drafting)</a:t>
             </a:r>
           </a:p>
           <a:p>
@@ -24365,7 +24369,7 @@
               </a:defRPr>
             </a:pPr>
             <a:r>
-              <a:t>•  Unified data layer linking CRM + inventory + telemetry</a:t>
+              <a:t>•  Unified data layer linking customers + inventory + usage</a:t>
             </a:r>
           </a:p>
           <a:p>
@@ -24381,7 +24385,7 @@
               </a:defRPr>
             </a:pPr>
             <a:r>
-              <a:t>•  AWS SageMaker for forecasting</a:t>
+              <a:t>•  AI-powered demand forecasting</a:t>
             </a:r>
           </a:p>
           <a:p>
@@ -24397,7 +24401,7 @@
               </a:defRPr>
             </a:pPr>
             <a:r>
-              <a:t>•  ERP system evaluation</a:t>
+              <a:t>•  Business systems evaluation</a:t>
             </a:r>
           </a:p>
         </p:txBody>
@@ -24555,7 +24559,7 @@
               </a:defRPr>
             </a:pPr>
             <a:r>
-              <a:t>•  Salesforce Einstein/Agentforce for OEM proposals</a:t>
+              <a:t>•  AI-assisted proposals for bike manufacturer deals</a:t>
             </a:r>
           </a:p>
           <a:p>
@@ -24571,7 +24575,7 @@
               </a:defRPr>
             </a:pPr>
             <a:r>
-              <a:t>•  Compatibility rules engine for recommendations</a:t>
+              <a:t>•  Part compatibility and recommendation engine</a:t>
             </a:r>
           </a:p>
           <a:p>
@@ -24777,7 +24781,7 @@
               </a:defRPr>
             </a:pPr>
             <a:r>
-              <a:t>•  Digital twin and generative design capability</a:t>
+              <a:t>•  AI-simulated product testing (digital twin)</a:t>
             </a:r>
           </a:p>
           <a:p>
@@ -25725,7 +25729,7 @@
               </a:defRPr>
             </a:pPr>
             <a:r>
-              <a:t>Drivetrains + Braking</a:t>
+              <a:t>Gears + Brakes</a:t>
             </a:r>
           </a:p>
         </p:txBody>
@@ -26049,7 +26053,7 @@
               </a:defRPr>
             </a:pPr>
             <a:r>
-              <a:t>Wheels + Cockpit</a:t>
+              <a:t>Wheels + Handlebars</a:t>
             </a:r>
           </a:p>
         </p:txBody>
@@ -26373,7 +26377,7 @@
               </a:defRPr>
             </a:pPr>
             <a:r>
-              <a:t>Cycling Computer</a:t>
+              <a:t>GPS Bike Computer</a:t>
             </a:r>
           </a:p>
         </p:txBody>
@@ -26618,7 +26622,7 @@
               </a:defRPr>
             </a:pPr>
             <a:r>
-              <a:t>AXS Wireless Ecosystem  |  All connected, all generating data</a:t>
+              <a:t>AXS Wireless Platform  |  All 6 brands connect wirelessly and share data</a:t>
             </a:r>
           </a:p>
         </p:txBody>
@@ -26744,7 +26748,7 @@
               </a:defRPr>
             </a:pPr>
             <a:r>
-              <a:t>“A Shimano rider uses the app to check compatibility. A Hammerhead rider uses it to train, navigate, and communicate with their component stack. That is a fundamentally different data relationship.”</a:t>
+              <a:t>“A rider on Shimano [SRAM's largest competitor] uses the app to check if parts fit. A Hammerhead rider uses it to train, navigate, and talk to every component on the bike. That is a fundamentally different data relationship.”</a:t>
             </a:r>
           </a:p>
         </p:txBody>
@@ -27540,7 +27544,7 @@
               </a:defRPr>
             </a:pPr>
             <a:r>
-              <a:t>Telemetry data is collected but unused</a:t>
+              <a:t>Rider data is collected but unused</a:t>
             </a:r>
           </a:p>
         </p:txBody>
@@ -28419,7 +28423,7 @@
               </a:defRPr>
             </a:pPr>
             <a:r>
-              <a:t>Telemetry data is collected but unused</a:t>
+              <a:t>Rider data is collected but unused</a:t>
             </a:r>
           </a:p>
         </p:txBody>
@@ -28700,7 +28704,7 @@
               </a:defRPr>
             </a:pPr>
             <a:r>
-              <a:t>OEM Proposal Automation</a:t>
+              <a:t>Bike Manufacturer Proposals</a:t>
             </a:r>
           </a:p>
         </p:txBody>
@@ -28938,7 +28942,7 @@
               </a:defRPr>
             </a:pPr>
             <a:r>
-              <a:t>DTC Personalization</a:t>
+              <a:t>Online Store Personalization</a:t>
             </a:r>
           </a:p>
         </p:txBody>
@@ -28974,7 +28978,7 @@
               </a:defRPr>
             </a:pPr>
             <a:r>
-              <a:t>Velocio has no targeting capability</a:t>
+              <a:t>SRAM's apparel brand has no targeting</a:t>
             </a:r>
           </a:p>
         </p:txBody>
@@ -29734,7 +29738,7 @@
               </a:defRPr>
             </a:pPr>
             <a:r>
-              <a:t>Telemetry data is collected but unused</a:t>
+              <a:t>Rider data is collected but unused</a:t>
             </a:r>
           </a:p>
         </p:txBody>
@@ -30015,7 +30019,7 @@
               </a:defRPr>
             </a:pPr>
             <a:r>
-              <a:t>OEM Proposal Automation</a:t>
+              <a:t>Bike Manufacturer Proposals</a:t>
             </a:r>
           </a:p>
         </p:txBody>
@@ -30253,7 +30257,7 @@
               </a:defRPr>
             </a:pPr>
             <a:r>
-              <a:t>DTC Personalization</a:t>
+              <a:t>Online Store Personalization</a:t>
             </a:r>
           </a:p>
         </p:txBody>
@@ -30289,7 +30293,7 @@
               </a:defRPr>
             </a:pPr>
             <a:r>
-              <a:t>Velocio has no targeting capability</a:t>
+              <a:t>SRAM's apparel brand has no targeting</a:t>
             </a:r>
           </a:p>
         </p:txBody>
@@ -30725,7 +30729,7 @@
               </a:defRPr>
             </a:pPr>
             <a:r>
-              <a:t>Shopify data is siloed, unused</a:t>
+              <a:t>E-commerce data is siloed, unused</a:t>
             </a:r>
           </a:p>
         </p:txBody>
@@ -31485,7 +31489,7 @@
               </a:defRPr>
             </a:pPr>
             <a:r>
-              <a:t>Telemetry data is collected but unused</a:t>
+              <a:t>Rider data is collected but unused</a:t>
             </a:r>
           </a:p>
         </p:txBody>
@@ -31766,7 +31770,7 @@
               </a:defRPr>
             </a:pPr>
             <a:r>
-              <a:t>OEM Proposal Automation</a:t>
+              <a:t>Bike Manufacturer Proposals</a:t>
             </a:r>
           </a:p>
         </p:txBody>
@@ -32004,7 +32008,7 @@
               </a:defRPr>
             </a:pPr>
             <a:r>
-              <a:t>DTC Personalization</a:t>
+              <a:t>Online Store Personalization</a:t>
             </a:r>
           </a:p>
         </p:txBody>
@@ -32040,7 +32044,7 @@
               </a:defRPr>
             </a:pPr>
             <a:r>
-              <a:t>Velocio has no targeting capability</a:t>
+              <a:t>SRAM's apparel brand has no targeting</a:t>
             </a:r>
           </a:p>
         </p:txBody>
@@ -32476,7 +32480,7 @@
               </a:defRPr>
             </a:pPr>
             <a:r>
-              <a:t>Shopify data is siloed, unused</a:t>
+              <a:t>E-commerce data is siloed, unused</a:t>
             </a:r>
           </a:p>
         </p:txBody>
@@ -33319,7 +33323,7 @@
               </a:defRPr>
             </a:pPr>
             <a:r>
-              <a:t>Riders love SRAM hardware. They struggle with firmware, compatibility, and warranty resolution.</a:t>
+              <a:t>Riders love SRAM hardware. They struggle with software updates, part compatibility, and warranty claims.</a:t>
             </a:r>
           </a:p>
         </p:txBody>
@@ -33748,7 +33752,7 @@
               </a:defRPr>
             </a:pPr>
             <a:r>
-              <a:t>Firmware + Pairing</a:t>
+              <a:t>Software Updates + Setup</a:t>
             </a:r>
           </a:p>
         </p:txBody>
@@ -34033,7 +34037,7 @@
               </a:defRPr>
             </a:pPr>
             <a:r>
-              <a:t>Riders love SRAM hardware. They struggle with firmware, compatibility, and warranty resolution.</a:t>
+              <a:t>Riders love SRAM hardware. They struggle with software updates, part compatibility, and warranty claims.</a:t>
             </a:r>
           </a:p>
         </p:txBody>
@@ -34462,7 +34466,7 @@
               </a:defRPr>
             </a:pPr>
             <a:r>
-              <a:t>Firmware + Pairing</a:t>
+              <a:t>Software Updates + Setup</a:t>
             </a:r>
           </a:p>
         </p:txBody>

</xml_diff>

<commit_message>
Restore specificity, keep only targeted accessibility fixes
Reverted most jargon simplifications. Kept: Shimano tagged as
largest competitor, clipless changed to clip-in, cockpit description
clarified, AXS ecosystem bar explains wireless data sharing.
Restored OEM, DTC, CRM, SLA, CSAT, Zendesk, Kendra, Bedrock,
Shopify, SageMaker, and other specific terms.
</commit_message>
<xml_diff>
--- a/deliverables/SRAM_AI_Adoption_Playbook.pptx
+++ b/deliverables/SRAM_AI_Adoption_Playbook.pptx
@@ -3625,7 +3625,7 @@
             </a:r>
             <a:br/>
             <a:r>
-              <a:t>submits a question</a:t>
+              <a:t>submits via Zendesk</a:t>
             </a:r>
           </a:p>
         </p:txBody>
@@ -3839,11 +3839,11 @@
               </a:defRPr>
             </a:pPr>
             <a:r>
-              <a:t>AI searches SRAM's</a:t>
+              <a:t>Amazon Kendra searches</a:t>
             </a:r>
             <a:br/>
             <a:r>
-              <a:t>approved documents</a:t>
+              <a:t>approved documentation</a:t>
             </a:r>
           </a:p>
         </p:txBody>
@@ -4057,11 +4057,11 @@
               </a:defRPr>
             </a:pPr>
             <a:r>
-              <a:t>AI writes a</a:t>
+              <a:t>Amazon Bedrock drafts</a:t>
             </a:r>
             <a:br/>
             <a:r>
-              <a:t>proposed answer</a:t>
+              <a:t>response from knowledge base</a:t>
             </a:r>
           </a:p>
         </p:txBody>
@@ -4275,7 +4275,7 @@
               </a:defRPr>
             </a:pPr>
             <a:r>
-              <a:t>Support agent approves</a:t>
+              <a:t>Agent approves</a:t>
             </a:r>
             <a:br/>
             <a:r>
@@ -4885,7 +4885,7 @@
             </a:r>
             <a:br/>
             <a:r>
-              <a:t>submits a question</a:t>
+              <a:t>submits via Zendesk</a:t>
             </a:r>
           </a:p>
         </p:txBody>
@@ -5099,11 +5099,11 @@
               </a:defRPr>
             </a:pPr>
             <a:r>
-              <a:t>AI searches SRAM's</a:t>
+              <a:t>Amazon Kendra searches</a:t>
             </a:r>
             <a:br/>
             <a:r>
-              <a:t>approved documents</a:t>
+              <a:t>approved documentation</a:t>
             </a:r>
           </a:p>
         </p:txBody>
@@ -5317,11 +5317,11 @@
               </a:defRPr>
             </a:pPr>
             <a:r>
-              <a:t>AI writes a</a:t>
+              <a:t>Amazon Bedrock drafts</a:t>
             </a:r>
             <a:br/>
             <a:r>
-              <a:t>proposed answer</a:t>
+              <a:t>response from knowledge base</a:t>
             </a:r>
           </a:p>
         </p:txBody>
@@ -5535,7 +5535,7 @@
               </a:defRPr>
             </a:pPr>
             <a:r>
-              <a:t>Support agent approves</a:t>
+              <a:t>Agent approves</a:t>
             </a:r>
             <a:br/>
             <a:r>
@@ -6411,7 +6411,7 @@
               </a:defRPr>
             </a:pPr>
             <a:r>
-              <a:t>Measured weekly vs. current baseline</a:t>
+              <a:t>Measured weekly vs. SLA baseline</a:t>
             </a:r>
           </a:p>
         </p:txBody>
@@ -6867,7 +6867,7 @@
               </a:defRPr>
             </a:pPr>
             <a:r>
-              <a:t>Measured weekly vs. current baseline</a:t>
+              <a:t>Measured weekly vs. SLA baseline</a:t>
             </a:r>
           </a:p>
         </p:txBody>
@@ -7485,7 +7485,7 @@
               </a:defRPr>
             </a:pPr>
             <a:r>
-              <a:t>Measured weekly vs. current baseline</a:t>
+              <a:t>Measured weekly vs. SLA baseline</a:t>
             </a:r>
           </a:p>
         </p:txBody>
@@ -8310,7 +8310,7 @@
               </a:defRPr>
             </a:pPr>
             <a:r>
-              <a:t>Measured weekly vs. current baseline</a:t>
+              <a:t>Measured weekly vs. SLA baseline</a:t>
             </a:r>
           </a:p>
         </p:txBody>
@@ -9297,7 +9297,7 @@
               </a:defRPr>
             </a:pPr>
             <a:r>
-              <a:t>Measured weekly vs. current baseline</a:t>
+              <a:t>Measured weekly vs. SLA baseline</a:t>
             </a:r>
           </a:p>
         </p:txBody>
@@ -10640,7 +10640,7 @@
               </a:defRPr>
             </a:pPr>
             <a:r>
-              <a:t>Connect support system to AI tools; set baseline metrics</a:t>
+              <a:t>Zendesk + Kendra + Bedrock integration; baseline metrics</a:t>
             </a:r>
           </a:p>
         </p:txBody>
@@ -11290,7 +11290,7 @@
               </a:defRPr>
             </a:pPr>
             <a:r>
-              <a:t>Connect support system to AI tools; set baseline metrics</a:t>
+              <a:t>Zendesk + Kendra + Bedrock integration; baseline metrics</a:t>
             </a:r>
           </a:p>
         </p:txBody>
@@ -12307,7 +12307,7 @@
               </a:defRPr>
             </a:pPr>
             <a:r>
-              <a:t>Satisfaction Monitoring</a:t>
+              <a:t>CSAT Monitoring</a:t>
             </a:r>
           </a:p>
         </p:txBody>
@@ -12993,7 +12993,7 @@
               </a:defRPr>
             </a:pPr>
             <a:r>
-              <a:t>Connect support system to AI tools; set baseline metrics</a:t>
+              <a:t>Zendesk + Kendra + Bedrock integration; baseline metrics</a:t>
             </a:r>
           </a:p>
         </p:txBody>
@@ -14010,7 +14010,7 @@
               </a:defRPr>
             </a:pPr>
             <a:r>
-              <a:t>Satisfaction Monitoring</a:t>
+              <a:t>CSAT Monitoring</a:t>
             </a:r>
           </a:p>
         </p:txBody>
@@ -14900,7 +14900,7 @@
               </a:defRPr>
             </a:pPr>
             <a:r>
-              <a:t>Gears + Brakes</a:t>
+              <a:t>Drivetrains + Braking</a:t>
             </a:r>
           </a:p>
         </p:txBody>
@@ -14936,11 +14936,11 @@
               </a:defRPr>
             </a:pPr>
             <a:r>
-              <a:t>The parts that make</a:t>
+              <a:t>Gears, chains, and disc</a:t>
             </a:r>
             <a:br/>
             <a:r>
-              <a:t>a bike shift and stop</a:t>
+              <a:t>brakes for every bike</a:t>
             </a:r>
           </a:p>
         </p:txBody>
@@ -15095,11 +15095,11 @@
               </a:defRPr>
             </a:pPr>
             <a:r>
-              <a:t>Shock absorbers that</a:t>
+              <a:t>Forks and shocks that</a:t>
             </a:r>
             <a:br/>
             <a:r>
-              <a:t>smooth out rough terrain</a:t>
+              <a:t>absorb trail impacts</a:t>
             </a:r>
           </a:p>
         </p:txBody>
@@ -15218,7 +15218,7 @@
               </a:defRPr>
             </a:pPr>
             <a:r>
-              <a:t>Wheels + Handlebars</a:t>
+              <a:t>Wheels + Cockpit</a:t>
             </a:r>
           </a:p>
         </p:txBody>
@@ -15254,11 +15254,11 @@
               </a:defRPr>
             </a:pPr>
             <a:r>
-              <a:t>Lightweight wheels</a:t>
+              <a:t>Aero wheels, handlebars,</a:t>
             </a:r>
             <a:br/>
             <a:r>
-              <a:t>built for speed</a:t>
+              <a:t>and stems</a:t>
             </a:r>
           </a:p>
         </p:txBody>
@@ -15417,7 +15417,7 @@
             </a:r>
             <a:br/>
             <a:r>
-              <a:t>how hard a rider pedals</a:t>
+              <a:t>rider output in watts</a:t>
             </a:r>
           </a:p>
         </p:txBody>
@@ -15572,7 +15572,7 @@
               </a:defRPr>
             </a:pPr>
             <a:r>
-              <a:t>On-bike screen for</a:t>
+              <a:t>On-bike computer for</a:t>
             </a:r>
             <a:br/>
             <a:r>
@@ -15731,11 +15731,11 @@
               </a:defRPr>
             </a:pPr>
             <a:r>
-              <a:t>Pedal systems that lock</a:t>
+              <a:t>Clip-in pedal systems</a:t>
             </a:r>
             <a:br/>
             <a:r>
-              <a:t>into the rider's shoes</a:t>
+              <a:t>for road and mountain</a:t>
             </a:r>
           </a:p>
         </p:txBody>
@@ -17268,7 +17268,7 @@
               </a:defRPr>
             </a:pPr>
             <a:r>
-              <a:t>Each capability creates a new recurring revenue stream. SRAM's millions of connected bike parts become a software platform, not a one-time sale.</a:t>
+              <a:t>Each capability creates a new recurring revenue stream. SRAM's installed base of connected components becomes a platform, not a one-time sale.</a:t>
             </a:r>
           </a:p>
         </p:txBody>
@@ -17466,7 +17466,7 @@
               </a:defRPr>
             </a:pPr>
             <a:r>
-              <a:t>One dashboard showing power, gearing, suspension, and heart rate. No competitor sells enough product categories to build this.</a:t>
+              <a:t>Unified rider dashboard: power, gearing, suspension, heart rate in one view. No competitor has the product breadth to build this.</a:t>
             </a:r>
           </a:p>
         </p:txBody>
@@ -17751,7 +17751,7 @@
               </a:defRPr>
             </a:pPr>
             <a:r>
-              <a:t>Each capability creates a new recurring revenue stream. SRAM's millions of connected bike parts become a software platform, not a one-time sale.</a:t>
+              <a:t>Each capability creates a new recurring revenue stream. SRAM's installed base of connected components becomes a platform, not a one-time sale.</a:t>
             </a:r>
           </a:p>
         </p:txBody>
@@ -17949,7 +17949,7 @@
               </a:defRPr>
             </a:pPr>
             <a:r>
-              <a:t>One dashboard showing power, gearing, suspension, and heart rate. No competitor sells enough product categories to build this.</a:t>
+              <a:t>Unified rider dashboard: power, gearing, suspension, heart rate in one view. No competitor has the product breadth to build this.</a:t>
             </a:r>
           </a:p>
         </p:txBody>
@@ -18104,7 +18104,7 @@
               </a:defRPr>
             </a:pPr>
             <a:r>
-              <a:t>Connected parts predict when chains and brake pads need replacement before they fail. One-time sales become recurring revenue.</a:t>
+              <a:t>Connected components predict chain and brake pad replacement before failure. Installed base becomes recurring revenue.</a:t>
             </a:r>
           </a:p>
         </p:txBody>
@@ -18259,7 +18259,7 @@
               </a:defRPr>
             </a:pPr>
             <a:r>
-              <a:t>Suspension auto-adjusts to terrain. Gears optimize for rider power. Products improve continuously after purchase.</a:t>
+              <a:t>Suspension auto-adjusts to terrain. Shifting optimizes for rider power. Products improve continuously after purchase.</a:t>
             </a:r>
           </a:p>
         </p:txBody>
@@ -18414,7 +18414,7 @@
               </a:defRPr>
             </a:pPr>
             <a:r>
-              <a:t>Usage data tells bike shops which parts are wearing out in their area. Proactive ordering replaces reactive.</a:t>
+              <a:t>Telemetry tells dealers which parts approach end-of-life in their area. Proactive ordering replaces reactive.</a:t>
             </a:r>
           </a:p>
         </p:txBody>
@@ -19357,15 +19357,11 @@
               </a:defRPr>
             </a:pPr>
             <a:r>
-              <a:t>Unified data layer linking customer records,</a:t>
+              <a:t>Unified data layer linking CRM, inventory,</a:t>
             </a:r>
             <a:br/>
             <a:r>
-              <a:t>inventory, and product usage data.</a:t>
-            </a:r>
-            <a:br/>
-            <a:r>
-              <a:t>Foundation for Phase 2-4.</a:t>
+              <a:t>and telemetry. Foundation for Phase 2-4.</a:t>
             </a:r>
           </a:p>
         </p:txBody>
@@ -20372,7 +20368,7 @@
               </a:defRPr>
             </a:pPr>
             <a:r>
-              <a:t>Unified data layer connecting e-commerce, support systems, and product usage data. Foundation for Phase 2 forecasting and Phase 4 AXS Intelligence platform.</a:t>
+              <a:t>Unified data layer connecting Shopify, support systems, and telemetry. Foundation for Phase 2 forecasting and Phase 4 AXS Intelligence platform.</a:t>
             </a:r>
           </a:p>
         </p:txBody>
@@ -24179,7 +24175,7 @@
               </a:defRPr>
             </a:pPr>
             <a:r>
-              <a:t>•  AI support tools (document search + response drafting)</a:t>
+              <a:t>•  Zendesk AI + Amazon Kendra + Bedrock</a:t>
             </a:r>
           </a:p>
           <a:p>
@@ -24369,7 +24365,7 @@
               </a:defRPr>
             </a:pPr>
             <a:r>
-              <a:t>•  Unified data layer linking customers + inventory + usage</a:t>
+              <a:t>•  Unified data layer linking CRM + inventory + telemetry</a:t>
             </a:r>
           </a:p>
           <a:p>
@@ -24385,7 +24381,7 @@
               </a:defRPr>
             </a:pPr>
             <a:r>
-              <a:t>•  AI-powered demand forecasting</a:t>
+              <a:t>•  AWS SageMaker for forecasting</a:t>
             </a:r>
           </a:p>
           <a:p>
@@ -24401,7 +24397,7 @@
               </a:defRPr>
             </a:pPr>
             <a:r>
-              <a:t>•  Business systems evaluation</a:t>
+              <a:t>•  ERP system evaluation</a:t>
             </a:r>
           </a:p>
         </p:txBody>
@@ -24559,7 +24555,7 @@
               </a:defRPr>
             </a:pPr>
             <a:r>
-              <a:t>•  AI-assisted proposals for bike manufacturer deals</a:t>
+              <a:t>•  Salesforce Einstein/Agentforce for OEM proposals</a:t>
             </a:r>
           </a:p>
           <a:p>
@@ -24575,7 +24571,7 @@
               </a:defRPr>
             </a:pPr>
             <a:r>
-              <a:t>•  Part compatibility and recommendation engine</a:t>
+              <a:t>•  Compatibility rules engine for recommendations</a:t>
             </a:r>
           </a:p>
           <a:p>
@@ -24781,7 +24777,7 @@
               </a:defRPr>
             </a:pPr>
             <a:r>
-              <a:t>•  AI-simulated product testing (digital twin)</a:t>
+              <a:t>•  Digital twin and generative design capability</a:t>
             </a:r>
           </a:p>
           <a:p>
@@ -25729,7 +25725,7 @@
               </a:defRPr>
             </a:pPr>
             <a:r>
-              <a:t>Gears + Brakes</a:t>
+              <a:t>Drivetrains + Braking</a:t>
             </a:r>
           </a:p>
         </p:txBody>
@@ -26053,7 +26049,7 @@
               </a:defRPr>
             </a:pPr>
             <a:r>
-              <a:t>Wheels + Handlebars</a:t>
+              <a:t>Wheels + Cockpit</a:t>
             </a:r>
           </a:p>
         </p:txBody>
@@ -26622,7 +26618,7 @@
               </a:defRPr>
             </a:pPr>
             <a:r>
-              <a:t>AXS Wireless Platform  |  All 6 brands connect wirelessly and share data</a:t>
+              <a:t>AXS Wireless Ecosystem  |  All 6 brands connect wirelessly and share data</a:t>
             </a:r>
           </a:p>
         </p:txBody>
@@ -27544,7 +27540,7 @@
               </a:defRPr>
             </a:pPr>
             <a:r>
-              <a:t>Rider data is collected but unused</a:t>
+              <a:t>Telemetry data is collected but unused</a:t>
             </a:r>
           </a:p>
         </p:txBody>
@@ -28423,7 +28419,7 @@
               </a:defRPr>
             </a:pPr>
             <a:r>
-              <a:t>Rider data is collected but unused</a:t>
+              <a:t>Telemetry data is collected but unused</a:t>
             </a:r>
           </a:p>
         </p:txBody>
@@ -28704,7 +28700,7 @@
               </a:defRPr>
             </a:pPr>
             <a:r>
-              <a:t>Bike Manufacturer Proposals</a:t>
+              <a:t>OEM Proposal Automation</a:t>
             </a:r>
           </a:p>
         </p:txBody>
@@ -28942,7 +28938,7 @@
               </a:defRPr>
             </a:pPr>
             <a:r>
-              <a:t>Online Store Personalization</a:t>
+              <a:t>DTC Personalization</a:t>
             </a:r>
           </a:p>
         </p:txBody>
@@ -28978,7 +28974,7 @@
               </a:defRPr>
             </a:pPr>
             <a:r>
-              <a:t>SRAM's apparel brand has no targeting</a:t>
+              <a:t>Velocio has no targeting capability</a:t>
             </a:r>
           </a:p>
         </p:txBody>
@@ -29738,7 +29734,7 @@
               </a:defRPr>
             </a:pPr>
             <a:r>
-              <a:t>Rider data is collected but unused</a:t>
+              <a:t>Telemetry data is collected but unused</a:t>
             </a:r>
           </a:p>
         </p:txBody>
@@ -30019,7 +30015,7 @@
               </a:defRPr>
             </a:pPr>
             <a:r>
-              <a:t>Bike Manufacturer Proposals</a:t>
+              <a:t>OEM Proposal Automation</a:t>
             </a:r>
           </a:p>
         </p:txBody>
@@ -30257,7 +30253,7 @@
               </a:defRPr>
             </a:pPr>
             <a:r>
-              <a:t>Online Store Personalization</a:t>
+              <a:t>DTC Personalization</a:t>
             </a:r>
           </a:p>
         </p:txBody>
@@ -30293,7 +30289,7 @@
               </a:defRPr>
             </a:pPr>
             <a:r>
-              <a:t>SRAM's apparel brand has no targeting</a:t>
+              <a:t>Velocio has no targeting capability</a:t>
             </a:r>
           </a:p>
         </p:txBody>
@@ -30729,7 +30725,7 @@
               </a:defRPr>
             </a:pPr>
             <a:r>
-              <a:t>E-commerce data is siloed, unused</a:t>
+              <a:t>Shopify data is siloed, unused</a:t>
             </a:r>
           </a:p>
         </p:txBody>
@@ -31489,7 +31485,7 @@
               </a:defRPr>
             </a:pPr>
             <a:r>
-              <a:t>Rider data is collected but unused</a:t>
+              <a:t>Telemetry data is collected but unused</a:t>
             </a:r>
           </a:p>
         </p:txBody>
@@ -31770,7 +31766,7 @@
               </a:defRPr>
             </a:pPr>
             <a:r>
-              <a:t>Bike Manufacturer Proposals</a:t>
+              <a:t>OEM Proposal Automation</a:t>
             </a:r>
           </a:p>
         </p:txBody>
@@ -32008,7 +32004,7 @@
               </a:defRPr>
             </a:pPr>
             <a:r>
-              <a:t>Online Store Personalization</a:t>
+              <a:t>DTC Personalization</a:t>
             </a:r>
           </a:p>
         </p:txBody>
@@ -32044,7 +32040,7 @@
               </a:defRPr>
             </a:pPr>
             <a:r>
-              <a:t>SRAM's apparel brand has no targeting</a:t>
+              <a:t>Velocio has no targeting capability</a:t>
             </a:r>
           </a:p>
         </p:txBody>
@@ -32480,7 +32476,7 @@
               </a:defRPr>
             </a:pPr>
             <a:r>
-              <a:t>E-commerce data is siloed, unused</a:t>
+              <a:t>Shopify data is siloed, unused</a:t>
             </a:r>
           </a:p>
         </p:txBody>
@@ -33323,7 +33319,7 @@
               </a:defRPr>
             </a:pPr>
             <a:r>
-              <a:t>Riders love SRAM hardware. They struggle with software updates, part compatibility, and warranty claims.</a:t>
+              <a:t>Riders love SRAM hardware. They struggle with firmware updates, part compatibility, and warranty resolution.</a:t>
             </a:r>
           </a:p>
         </p:txBody>
@@ -33752,7 +33748,7 @@
               </a:defRPr>
             </a:pPr>
             <a:r>
-              <a:t>Software Updates + Setup</a:t>
+              <a:t>Firmware + Pairing</a:t>
             </a:r>
           </a:p>
         </p:txBody>
@@ -34037,7 +34033,7 @@
               </a:defRPr>
             </a:pPr>
             <a:r>
-              <a:t>Riders love SRAM hardware. They struggle with software updates, part compatibility, and warranty claims.</a:t>
+              <a:t>Riders love SRAM hardware. They struggle with firmware updates, part compatibility, and warranty resolution.</a:t>
             </a:r>
           </a:p>
         </p:txBody>
@@ -34466,7 +34462,7 @@
               </a:defRPr>
             </a:pPr>
             <a:r>
-              <a:t>Software Updates + Setup</a:t>
+              <a:t>Firmware + Pairing</a:t>
             </a:r>
           </a:p>
         </p:txBody>

</xml_diff>

<commit_message>
Replace Jordan Hartsell interview with Clint Weber throughout
Delete old Hartsell interview files and update all references
across the playbook, citations version, presentation, roadmap
deck, and CLAUDE.md to use Clint Weber (VP Global Sales and
Manufacturing) quotes from the simulated interview. Rebuild
analysis hub and presentation.
</commit_message>
<xml_diff>
--- a/deliverables/SRAM_AI_Adoption_Playbook.pptx
+++ b/deliverables/SRAM_AI_Adoption_Playbook.pptx
@@ -5387,7 +5387,7 @@
               </a:defRPr>
             </a:pPr>
             <a:r>
-              <a:t>“I would rather shut it down and restart than defend a mistake to Ken. The first question I ask anyone skeptical about AI is: do you want to spend your day searching a 200-page compatibility PDF, or do you want to spend it talking to dealers?”</a:t>
+              <a:t>“If it doesn't hit the metric, you shut it down, you learn from it, and you redeploy the resources. That discipline is what separates companies that build real AI capability from companies that accumulate AI debt.”</a:t>
             </a:r>
           </a:p>
         </p:txBody>
@@ -5423,7 +5423,7 @@
               </a:defRPr>
             </a:pPr>
             <a:r>
-              <a:t>Jordan Hartsell, VP Digital Products, SRAM</a:t>
+              <a:t>Clint Weber, VP Global Sales &amp; Manufacturing, SRAM</a:t>
             </a:r>
           </a:p>
         </p:txBody>
@@ -5672,7 +5672,7 @@
               </a:defRPr>
             </a:pPr>
             <a:r>
-              <a:t>Hartsell set the bar: "One workflow measurably faster, measurably more accurate, with no regression in dealer satisfaction scores."</a:t>
+              <a:t>Weber set the bar: a 30% reduction in handle time on AXS support tickets with dealer satisfaction scores holding flat or improving.</a:t>
             </a:r>
           </a:p>
         </p:txBody>
@@ -6128,7 +6128,7 @@
               </a:defRPr>
             </a:pPr>
             <a:r>
-              <a:t>Hartsell set the bar: "One workflow measurably faster, measurably more accurate, with no regression in dealer satisfaction scores."</a:t>
+              <a:t>Weber set the bar: a 30% reduction in handle time on AXS support tickets with dealer satisfaction scores holding flat or improving.</a:t>
             </a:r>
           </a:p>
         </p:txBody>
@@ -6746,7 +6746,7 @@
               </a:defRPr>
             </a:pPr>
             <a:r>
-              <a:t>Hartsell set the bar: "One workflow measurably faster, measurably more accurate, with no regression in dealer satisfaction scores."</a:t>
+              <a:t>Weber set the bar: a 30% reduction in handle time on AXS support tickets with dealer satisfaction scores holding flat or improving.</a:t>
             </a:r>
           </a:p>
         </p:txBody>
@@ -7571,7 +7571,7 @@
               </a:defRPr>
             </a:pPr>
             <a:r>
-              <a:t>Hartsell set the bar: "One workflow measurably faster, measurably more accurate, with no regression in dealer satisfaction scores."</a:t>
+              <a:t>Weber set the bar: a 30% reduction in handle time on AXS support tickets with dealer satisfaction scores holding flat or improving.</a:t>
             </a:r>
           </a:p>
         </p:txBody>
@@ -8558,7 +8558,7 @@
               </a:defRPr>
             </a:pPr>
             <a:r>
-              <a:t>Hartsell set the bar: "One workflow measurably faster, measurably more accurate, with no regression in dealer satisfaction scores."</a:t>
+              <a:t>Weber set the bar: a 30% reduction in handle time on AXS support tickets with dealer satisfaction scores holding flat or improving.</a:t>
             </a:r>
           </a:p>
         </p:txBody>
@@ -19147,11 +19147,11 @@
               </a:defRPr>
             </a:pPr>
             <a:r>
-              <a:t>No confirmed executive sponsor above</a:t>
+              <a:t>Weber: 'Somebody at the C-suite level</a:t>
             </a:r>
             <a:br/>
             <a:r>
-              <a:t>Hartsell for the data consolidation roadmap.</a:t>
+              <a:t>needs to own it. Not as a side responsibility.'</a:t>
             </a:r>
             <a:br/>
             <a:r>
@@ -19281,7 +19281,7 @@
               </a:defRPr>
             </a:pPr>
             <a:r>
-              <a:t>“We are 60 to 70 percent of the way to deploying a bounded support assistant for AXS and Hammerhead products.”</a:t>
+              <a:t>“We are 60 to 70 percent of the way to AI-ready data in the AXS and Hammerhead domain.”</a:t>
             </a:r>
           </a:p>
         </p:txBody>
@@ -19317,7 +19317,7 @@
               </a:defRPr>
             </a:pPr>
             <a:r>
-              <a:t>Jordan Hartsell, VP Digital Products, SRAM</a:t>
+              <a:t>Clint Weber, VP Global Sales &amp; Manufacturing, SRAM</a:t>
             </a:r>
           </a:p>
         </p:txBody>
@@ -19890,7 +19890,7 @@
               </a:defRPr>
             </a:pPr>
             <a:r>
-              <a:t>Hartsell owns digital products but not the CRM, ERP, or inventory systems. Phase 2 requires a unified data layer across those systems. Without a senior sponsor, data integration stalls and the pilot stays isolated.</a:t>
+              <a:t>Weber owns sales and manufacturing but not the CRM, ERP, or inventory systems. Phase 2 requires a unified data layer across those systems. Without a senior sponsor, data integration stalls and the pilot stays isolated.</a:t>
             </a:r>
           </a:p>
         </p:txBody>
@@ -23248,7 +23248,7 @@
               </a:defRPr>
             </a:pPr>
             <a:r>
-              <a:t>Interview with Jordan Hartsell, VP Digital Products</a:t>
+              <a:t>Simulated Interview with Clint Weber, VP Global Sales &amp; Manufacturing</a:t>
             </a:r>
           </a:p>
         </p:txBody>
@@ -23327,7 +23327,7 @@
               </a:defRPr>
             </a:pPr>
             <a:r>
-              <a:t>45-minute Zoom call  |  March 2026  |  Key quotes and insights</a:t>
+              <a:t>AI-simulated interview  |  March 2026  |  Key quotes and insights</a:t>
             </a:r>
           </a:p>
         </p:txBody>
@@ -23489,7 +23489,7 @@
               </a:defRPr>
             </a:pPr>
             <a:r>
-              <a:t>“We have good data in pockets and messy data everywhere else. If I wanted to build a support AI today, I could get it to work well for AXS and Hammerhead. The moment a dealer asks about a RockShox fork on a 2019 frame with a third-party brake, I start to sweat.”</a:t>
+              <a:t>“The areas where we've under-invested in process, data, and cross-functional integration are exactly the areas where AI could close the gap fastest. Customer support. Demand forecasting. Compatibility and documentation management.”</a:t>
             </a:r>
           </a:p>
         </p:txBody>
@@ -23651,7 +23651,7 @@
               </a:defRPr>
             </a:pPr>
             <a:r>
-              <a:t>ON ADOPTION BARRIERS</a:t>
+              <a:t>ON CULTURAL BARRIERS</a:t>
             </a:r>
           </a:p>
         </p:txBody>
@@ -23687,7 +23687,7 @@
               </a:defRPr>
             </a:pPr>
             <a:r>
-              <a:t>“The resistance comes from customer-facing teams because they worry AI will produce confident-sounding wrong answers that damage dealer relationships they have spent years building.”</a:t>
+              <a:t>“We built a Formula 1 car and then had a regional pit crew. The support infrastructure has lagged behind the hardware. That is a cultural artifact as much as a resource one.”</a:t>
             </a:r>
           </a:p>
         </p:txBody>
@@ -23885,7 +23885,7 @@
               </a:defRPr>
             </a:pPr>
             <a:r>
-              <a:t>“A rider on Shimano [SRAM's largest competitor] uses the app to check if parts fit. A Hammerhead rider uses it to train, navigate, and talk to every component on the bike. That is a fundamentally different data relationship.”</a:t>
+              <a:t>“Shimano riders use an app to check compatibility. Our riders use an ecosystem to train, navigate, tune their suspension, and monitor their entire component stack in real time. That rider does not churn.”</a:t>
             </a:r>
           </a:p>
         </p:txBody>
@@ -24047,7 +24047,7 @@
               </a:defRPr>
             </a:pPr>
             <a:r>
-              <a:t>ON SUCCESS CRITERIA</a:t>
+              <a:t>ON IMPLEMENTATION DISCIPLINE</a:t>
             </a:r>
           </a:p>
         </p:txBody>
@@ -24083,7 +24083,7 @@
               </a:defRPr>
             </a:pPr>
             <a:r>
-              <a:t>“I want one workflow measurably faster, measurably more accurate, with no regression in dealer satisfaction scores.”</a:t>
+              <a:t>“If it doesn't hit the metric, you shut it down, you learn from it, and you redeploy the resources. That discipline is what separates companies that build real AI capability from companies that accumulate AI debt.”</a:t>
             </a:r>
           </a:p>
         </p:txBody>
@@ -27055,7 +27055,7 @@
               </a:defRPr>
             </a:pPr>
             <a:r>
-              <a:t>“A rider on Shimano [SRAM's largest competitor] uses the app to check if parts fit. A Hammerhead rider uses it to train, navigate, and talk to every component on the bike. That is a fundamentally different data relationship.”</a:t>
+              <a:t>“Shimano riders use an app to check compatibility. Our riders use an ecosystem to train, navigate, tune their suspension, and monitor their entire component stack in real time. That is a fundamentally different level of engagement.”</a:t>
             </a:r>
           </a:p>
         </p:txBody>
@@ -27091,7 +27091,7 @@
               </a:defRPr>
             </a:pPr>
             <a:r>
-              <a:t>Jordan Hartsell, VP Digital Products, SRAM</a:t>
+              <a:t>Clint Weber, VP Global Sales &amp; Manufacturing, SRAM</a:t>
             </a:r>
           </a:p>
         </p:txBody>
@@ -35007,7 +35007,7 @@
               </a:defRPr>
             </a:pPr>
             <a:r>
-              <a:t>Jordan Hartsell, VP Digital Products, SRAM</a:t>
+              <a:t>Clint Weber, VP Global Sales &amp; Manufacturing, SRAM</a:t>
             </a:r>
           </a:p>
         </p:txBody>

</xml_diff>